<commit_message>
Add Q&A slide on early fusion mechanism (concat vs gated)
Adds slide 17 answering the lecturer's question on whether the
project's early fusion is concat or gated/learnable. Evidence shows
input-level channel concatenation (4-channel: RGB + landmark heatmap),
not learnable gating — references EmotionEarlyFusion(Transfer) in
src/training/models.py and notes torch.cat is only used in
Intermediate Fusion.

Co-Authored-By: Claude Opus 4.7 (1M context) <noreply@anthropic.com>
</commit_message>
<xml_diff>
--- a/docs/cnn1d_geometric_results.pptx
+++ b/docs/cnn1d_geometric_results.pptx
@@ -21,6 +21,7 @@
     <p:sldId id="269" r:id="rId20"/>
     <p:sldId id="270" r:id="rId21"/>
     <p:sldId id="271" r:id="rId22"/>
+    <p:sldId id="272" r:id="rId23"/>
   </p:sldIdLst>
   <p:sldSz cx="12191695" cy="6858000" type="screen4x3"/>
   <p:notesSz cx="6858000" cy="9144000"/>
@@ -3738,7 +3739,7 @@
                 </a:solidFill>
                 <a:latin typeface="Calibri"/>
               </a:rPr>
-              <a:t>10 / 16</a:t>
+              <a:t>10 / 17</a:t>
             </a:r>
           </a:p>
         </p:txBody>
@@ -4749,7 +4750,7 @@
                 </a:solidFill>
                 <a:latin typeface="Calibri"/>
               </a:rPr>
-              <a:t>11 / 16</a:t>
+              <a:t>11 / 17</a:t>
             </a:r>
           </a:p>
         </p:txBody>
@@ -5609,7 +5610,7 @@
                 </a:solidFill>
                 <a:latin typeface="Calibri"/>
               </a:rPr>
-              <a:t>12 / 16</a:t>
+              <a:t>12 / 17</a:t>
             </a:r>
           </a:p>
         </p:txBody>
@@ -6549,7 +6550,7 @@
                 </a:solidFill>
                 <a:latin typeface="Calibri"/>
               </a:rPr>
-              <a:t>13 / 16</a:t>
+              <a:t>13 / 17</a:t>
             </a:r>
           </a:p>
         </p:txBody>
@@ -8642,7 +8643,7 @@
                 </a:solidFill>
                 <a:latin typeface="Calibri"/>
               </a:rPr>
-              <a:t>14 / 16</a:t>
+              <a:t>14 / 17</a:t>
             </a:r>
           </a:p>
         </p:txBody>
@@ -10852,7 +10853,7 @@
                 </a:solidFill>
                 <a:latin typeface="Calibri"/>
               </a:rPr>
-              <a:t>15 / 16</a:t>
+              <a:t>15 / 17</a:t>
             </a:r>
           </a:p>
         </p:txBody>
@@ -12024,7 +12025,7 @@
                 </a:solidFill>
                 <a:latin typeface="Calibri"/>
               </a:rPr>
-              <a:t>16 / 16</a:t>
+              <a:t>16 / 17</a:t>
             </a:r>
           </a:p>
         </p:txBody>
@@ -13214,16 +13215,227 @@
           </a:p>
         </p:txBody>
       </p:sp>
-      <p:sp>
-        <p:nvSpPr>
-          <p:cNvPr id="35" name="Rectangle 34"/>
+    </p:spTree>
+  </p:cSld>
+  <p:clrMapOvr>
+    <a:masterClrMapping/>
+  </p:clrMapOvr>
+</p:sld>
+</file>
+
+<file path=ppt/slides/slide17.xml><?xml version="1.0" encoding="utf-8"?>
+<p:sld xmlns:a="http://schemas.openxmlformats.org/drawingml/2006/main" xmlns:p="http://schemas.openxmlformats.org/presentationml/2006/main" xmlns:r="http://schemas.openxmlformats.org/officeDocument/2006/relationships">
+  <p:cSld>
+    <p:spTree>
+      <p:nvGrpSpPr>
+        <p:cNvPr id="1" name=""/>
+        <p:cNvGrpSpPr/>
+        <p:nvPr/>
+      </p:nvGrpSpPr>
+      <p:grpSpPr/>
+      <p:sp>
+        <p:nvSpPr>
+          <p:cNvPr id="2" name="Rectangle 1"/>
           <p:cNvSpPr/>
           <p:nvPr/>
         </p:nvSpPr>
         <p:spPr>
           <a:xfrm>
-            <a:off x="457200" y="6126480"/>
-            <a:ext cx="11247120" cy="320040"/>
+            <a:off x="0" y="0"/>
+            <a:ext cx="164592" cy="6858000"/>
+          </a:xfrm>
+          <a:prstGeom prst="rect">
+            <a:avLst/>
+          </a:prstGeom>
+          <a:solidFill>
+            <a:srgbClr val="1E3A5F"/>
+          </a:solidFill>
+          <a:ln>
+            <a:noFill/>
+          </a:ln>
+          <a:effectLst/>
+        </p:spPr>
+        <p:style>
+          <a:lnRef idx="1">
+            <a:schemeClr val="accent1"/>
+          </a:lnRef>
+          <a:fillRef idx="3">
+            <a:schemeClr val="accent1"/>
+          </a:fillRef>
+          <a:effectRef idx="2">
+            <a:schemeClr val="accent1"/>
+          </a:effectRef>
+          <a:fontRef idx="minor">
+            <a:schemeClr val="lt1"/>
+          </a:fontRef>
+        </p:style>
+        <p:txBody>
+          <a:bodyPr rtlCol="0" anchor="ctr"/>
+          <a:lstStyle/>
+          <a:p>
+            <a:pPr algn="ctr"/>
+          </a:p>
+        </p:txBody>
+      </p:sp>
+      <p:sp>
+        <p:nvSpPr>
+          <p:cNvPr id="3" name="TextBox 2"/>
+          <p:cNvSpPr txBox="1"/>
+          <p:nvPr/>
+        </p:nvSpPr>
+        <p:spPr>
+          <a:xfrm>
+            <a:off x="457200" y="292608"/>
+            <a:ext cx="10058400" cy="548640"/>
+          </a:xfrm>
+          <a:prstGeom prst="rect">
+            <a:avLst/>
+          </a:prstGeom>
+          <a:noFill/>
+        </p:spPr>
+        <p:txBody>
+          <a:bodyPr wrap="square" lIns="45720" rIns="45720" tIns="18288" bIns="18288" anchor="t">
+            <a:spAutoFit/>
+          </a:bodyPr>
+          <a:lstStyle/>
+          <a:p>
+            <a:pPr algn="l"/>
+            <a:r>
+              <a:rPr sz="2600" b="1" i="0">
+                <a:solidFill>
+                  <a:srgbClr val="1E3A5F"/>
+                </a:solidFill>
+                <a:latin typeface="Calibri"/>
+              </a:rPr>
+              <a:t>Q&amp;A — Mekanisme Early Fusion di Project Ini</a:t>
+            </a:r>
+          </a:p>
+        </p:txBody>
+      </p:sp>
+      <p:sp>
+        <p:nvSpPr>
+          <p:cNvPr id="4" name="TextBox 3"/>
+          <p:cNvSpPr txBox="1"/>
+          <p:nvPr/>
+        </p:nvSpPr>
+        <p:spPr>
+          <a:xfrm>
+            <a:off x="11155680" y="292608"/>
+            <a:ext cx="822960" cy="365760"/>
+          </a:xfrm>
+          <a:prstGeom prst="rect">
+            <a:avLst/>
+          </a:prstGeom>
+          <a:noFill/>
+        </p:spPr>
+        <p:txBody>
+          <a:bodyPr wrap="square" lIns="45720" rIns="45720" tIns="18288" bIns="18288" anchor="t">
+            <a:spAutoFit/>
+          </a:bodyPr>
+          <a:lstStyle/>
+          <a:p>
+            <a:pPr algn="r"/>
+            <a:r>
+              <a:rPr sz="1100" b="0" i="0">
+                <a:solidFill>
+                  <a:srgbClr val="64748B"/>
+                </a:solidFill>
+                <a:latin typeface="Calibri"/>
+              </a:rPr>
+              <a:t>17 / 17</a:t>
+            </a:r>
+          </a:p>
+        </p:txBody>
+      </p:sp>
+      <p:sp>
+        <p:nvSpPr>
+          <p:cNvPr id="5" name="Rectangle 4"/>
+          <p:cNvSpPr/>
+          <p:nvPr/>
+        </p:nvSpPr>
+        <p:spPr>
+          <a:xfrm>
+            <a:off x="457200" y="914400"/>
+            <a:ext cx="11247120" cy="12000"/>
+          </a:xfrm>
+          <a:prstGeom prst="rect">
+            <a:avLst/>
+          </a:prstGeom>
+          <a:solidFill>
+            <a:srgbClr val="E2E8F0"/>
+          </a:solidFill>
+          <a:ln>
+            <a:noFill/>
+          </a:ln>
+          <a:effectLst/>
+        </p:spPr>
+        <p:style>
+          <a:lnRef idx="1">
+            <a:schemeClr val="accent1"/>
+          </a:lnRef>
+          <a:fillRef idx="3">
+            <a:schemeClr val="accent1"/>
+          </a:fillRef>
+          <a:effectRef idx="2">
+            <a:schemeClr val="accent1"/>
+          </a:effectRef>
+          <a:fontRef idx="minor">
+            <a:schemeClr val="lt1"/>
+          </a:fontRef>
+        </p:style>
+        <p:txBody>
+          <a:bodyPr rtlCol="0" anchor="ctr"/>
+          <a:lstStyle/>
+          <a:p>
+            <a:pPr algn="ctr"/>
+          </a:p>
+        </p:txBody>
+      </p:sp>
+      <p:sp>
+        <p:nvSpPr>
+          <p:cNvPr id="6" name="TextBox 5"/>
+          <p:cNvSpPr txBox="1"/>
+          <p:nvPr/>
+        </p:nvSpPr>
+        <p:spPr>
+          <a:xfrm>
+            <a:off x="457200" y="6492240"/>
+            <a:ext cx="10058400" cy="274320"/>
+          </a:xfrm>
+          <a:prstGeom prst="rect">
+            <a:avLst/>
+          </a:prstGeom>
+          <a:noFill/>
+        </p:spPr>
+        <p:txBody>
+          <a:bodyPr wrap="square" lIns="45720" rIns="45720" tIns="18288" bIns="18288" anchor="t">
+            <a:spAutoFit/>
+          </a:bodyPr>
+          <a:lstStyle/>
+          <a:p>
+            <a:pPr algn="l"/>
+            <a:r>
+              <a:rPr sz="900" b="0" i="0">
+                <a:solidFill>
+                  <a:srgbClr val="64748B"/>
+                </a:solidFill>
+                <a:latin typeface="Calibri"/>
+              </a:rPr>
+              <a:t>Eksplorasi CNN1D Fitur Geometrik  ·  FER Multimodal  ·  Mei 2026</a:t>
+            </a:r>
+          </a:p>
+        </p:txBody>
+      </p:sp>
+      <p:sp>
+        <p:nvSpPr>
+          <p:cNvPr id="7" name="Rectangle 6"/>
+          <p:cNvSpPr/>
+          <p:nvPr/>
+        </p:nvSpPr>
+        <p:spPr>
+          <a:xfrm>
+            <a:off x="457200" y="1097280"/>
+            <a:ext cx="7315200" cy="822960"/>
           </a:xfrm>
           <a:prstGeom prst="rect">
             <a:avLst/>
@@ -13260,14 +13472,58 @@
       </p:sp>
       <p:sp>
         <p:nvSpPr>
-          <p:cNvPr id="36" name="TextBox 35"/>
+          <p:cNvPr id="8" name="Rectangle 7"/>
+          <p:cNvSpPr/>
+          <p:nvPr/>
+        </p:nvSpPr>
+        <p:spPr>
+          <a:xfrm>
+            <a:off x="457200" y="1097280"/>
+            <a:ext cx="109728" cy="822960"/>
+          </a:xfrm>
+          <a:prstGeom prst="rect">
+            <a:avLst/>
+          </a:prstGeom>
+          <a:solidFill>
+            <a:srgbClr val="E63946"/>
+          </a:solidFill>
+          <a:ln>
+            <a:noFill/>
+          </a:ln>
+          <a:effectLst/>
+        </p:spPr>
+        <p:style>
+          <a:lnRef idx="1">
+            <a:schemeClr val="accent1"/>
+          </a:lnRef>
+          <a:fillRef idx="3">
+            <a:schemeClr val="accent1"/>
+          </a:fillRef>
+          <a:effectRef idx="2">
+            <a:schemeClr val="accent1"/>
+          </a:effectRef>
+          <a:fontRef idx="minor">
+            <a:schemeClr val="lt1"/>
+          </a:fontRef>
+        </p:style>
+        <p:txBody>
+          <a:bodyPr rtlCol="0" anchor="ctr"/>
+          <a:lstStyle/>
+          <a:p>
+            <a:pPr algn="ctr"/>
+          </a:p>
+        </p:txBody>
+      </p:sp>
+      <p:sp>
+        <p:nvSpPr>
+          <p:cNvPr id="9" name="TextBox 8"/>
           <p:cNvSpPr txBox="1"/>
           <p:nvPr/>
         </p:nvSpPr>
         <p:spPr>
           <a:xfrm>
-            <a:off x="457200" y="6153912"/>
-            <a:ext cx="11247120" cy="274320"/>
+            <a:off x="777240" y="1170432"/>
+            <a:ext cx="6858000" cy="320040"/>
           </a:xfrm>
           <a:prstGeom prst="rect">
             <a:avLst/>
@@ -13280,19 +13536,1360 @@
           </a:bodyPr>
           <a:lstStyle/>
           <a:p>
+            <a:pPr algn="l"/>
+            <a:r>
+              <a:rPr sz="1000" b="1" i="0">
+                <a:solidFill>
+                  <a:srgbClr val="E63946"/>
+                </a:solidFill>
+                <a:latin typeface="Calibri"/>
+              </a:rPr>
+              <a:t>PERTANYAAN DOSEN</a:t>
+            </a:r>
+          </a:p>
+        </p:txBody>
+      </p:sp>
+      <p:sp>
+        <p:nvSpPr>
+          <p:cNvPr id="10" name="TextBox 9"/>
+          <p:cNvSpPr txBox="1"/>
+          <p:nvPr/>
+        </p:nvSpPr>
+        <p:spPr>
+          <a:xfrm>
+            <a:off x="777240" y="1417320"/>
+            <a:ext cx="6858000" cy="457200"/>
+          </a:xfrm>
+          <a:prstGeom prst="rect">
+            <a:avLst/>
+          </a:prstGeom>
+          <a:noFill/>
+        </p:spPr>
+        <p:txBody>
+          <a:bodyPr wrap="square" lIns="45720" rIns="45720" tIns="18288" bIns="18288" anchor="t">
+            <a:spAutoFit/>
+          </a:bodyPr>
+          <a:lstStyle/>
+          <a:p>
+            <a:pPr algn="l"/>
+            <a:r>
+              <a:rPr sz="1300" b="0" i="1">
+                <a:solidFill>
+                  <a:srgbClr val="1E293B"/>
+                </a:solidFill>
+                <a:latin typeface="Calibri"/>
+              </a:rPr>
+              <a:t>“Cek early fusion di project ini — concat atau gated (learnable)?”</a:t>
+            </a:r>
+          </a:p>
+        </p:txBody>
+      </p:sp>
+      <p:sp>
+        <p:nvSpPr>
+          <p:cNvPr id="11" name="Rectangle 10"/>
+          <p:cNvSpPr/>
+          <p:nvPr/>
+        </p:nvSpPr>
+        <p:spPr>
+          <a:xfrm>
+            <a:off x="7955279" y="1097280"/>
+            <a:ext cx="3749039" cy="822960"/>
+          </a:xfrm>
+          <a:prstGeom prst="rect">
+            <a:avLst/>
+          </a:prstGeom>
+          <a:solidFill>
+            <a:srgbClr val="10B981"/>
+          </a:solidFill>
+          <a:ln>
+            <a:noFill/>
+          </a:ln>
+          <a:effectLst/>
+        </p:spPr>
+        <p:style>
+          <a:lnRef idx="1">
+            <a:schemeClr val="accent1"/>
+          </a:lnRef>
+          <a:fillRef idx="3">
+            <a:schemeClr val="accent1"/>
+          </a:fillRef>
+          <a:effectRef idx="2">
+            <a:schemeClr val="accent1"/>
+          </a:effectRef>
+          <a:fontRef idx="minor">
+            <a:schemeClr val="lt1"/>
+          </a:fontRef>
+        </p:style>
+        <p:txBody>
+          <a:bodyPr rtlCol="0" anchor="ctr"/>
+          <a:lstStyle/>
+          <a:p>
             <a:pPr algn="ctr"/>
+          </a:p>
+        </p:txBody>
+      </p:sp>
+      <p:sp>
+        <p:nvSpPr>
+          <p:cNvPr id="12" name="TextBox 11"/>
+          <p:cNvSpPr txBox="1"/>
+          <p:nvPr/>
+        </p:nvSpPr>
+        <p:spPr>
+          <a:xfrm>
+            <a:off x="8092440" y="1170432"/>
+            <a:ext cx="3474720" cy="274320"/>
+          </a:xfrm>
+          <a:prstGeom prst="rect">
+            <a:avLst/>
+          </a:prstGeom>
+          <a:noFill/>
+        </p:spPr>
+        <p:txBody>
+          <a:bodyPr wrap="square" lIns="45720" rIns="45720" tIns="18288" bIns="18288" anchor="t">
+            <a:spAutoFit/>
+          </a:bodyPr>
+          <a:lstStyle/>
+          <a:p>
+            <a:pPr algn="l"/>
+            <a:r>
+              <a:rPr sz="1000" b="1" i="0">
+                <a:solidFill>
+                  <a:srgbClr val="FFFFFF"/>
+                </a:solidFill>
+                <a:latin typeface="Calibri"/>
+              </a:rPr>
+              <a:t>JAWABAN</a:t>
+            </a:r>
+          </a:p>
+        </p:txBody>
+      </p:sp>
+      <p:sp>
+        <p:nvSpPr>
+          <p:cNvPr id="13" name="TextBox 12"/>
+          <p:cNvSpPr txBox="1"/>
+          <p:nvPr/>
+        </p:nvSpPr>
+        <p:spPr>
+          <a:xfrm>
+            <a:off x="8092440" y="1371600"/>
+            <a:ext cx="3474720" cy="502920"/>
+          </a:xfrm>
+          <a:prstGeom prst="rect">
+            <a:avLst/>
+          </a:prstGeom>
+          <a:noFill/>
+        </p:spPr>
+        <p:txBody>
+          <a:bodyPr wrap="square" lIns="45720" rIns="45720" tIns="18288" bIns="18288" anchor="t">
+            <a:spAutoFit/>
+          </a:bodyPr>
+          <a:lstStyle/>
+          <a:p>
+            <a:pPr algn="l"/>
+            <a:r>
+              <a:rPr sz="1600" b="1" i="0">
+                <a:solidFill>
+                  <a:srgbClr val="FFFFFF"/>
+                </a:solidFill>
+                <a:latin typeface="Calibri"/>
+              </a:rPr>
+              <a:t>CONCAT (channel stacking)</a:t>
+            </a:r>
+          </a:p>
+        </p:txBody>
+      </p:sp>
+      <p:sp>
+        <p:nvSpPr>
+          <p:cNvPr id="14" name="Rectangle 13"/>
+          <p:cNvSpPr/>
+          <p:nvPr/>
+        </p:nvSpPr>
+        <p:spPr>
+          <a:xfrm>
+            <a:off x="457200" y="2103120"/>
+            <a:ext cx="5577840" cy="2194560"/>
+          </a:xfrm>
+          <a:prstGeom prst="rect">
+            <a:avLst/>
+          </a:prstGeom>
+          <a:solidFill>
+            <a:srgbClr val="FFFFFF"/>
+          </a:solidFill>
+          <a:ln w="12700">
+            <a:solidFill>
+              <a:srgbClr val="E2E8F0"/>
+            </a:solidFill>
+          </a:ln>
+          <a:effectLst/>
+        </p:spPr>
+        <p:style>
+          <a:lnRef idx="1">
+            <a:schemeClr val="accent1"/>
+          </a:lnRef>
+          <a:fillRef idx="3">
+            <a:schemeClr val="accent1"/>
+          </a:fillRef>
+          <a:effectRef idx="2">
+            <a:schemeClr val="accent1"/>
+          </a:effectRef>
+          <a:fontRef idx="minor">
+            <a:schemeClr val="lt1"/>
+          </a:fontRef>
+        </p:style>
+        <p:txBody>
+          <a:bodyPr rtlCol="0" anchor="ctr"/>
+          <a:lstStyle/>
+          <a:p>
+            <a:pPr algn="ctr"/>
+          </a:p>
+        </p:txBody>
+      </p:sp>
+      <p:sp>
+        <p:nvSpPr>
+          <p:cNvPr id="15" name="Rectangle 14"/>
+          <p:cNvSpPr/>
+          <p:nvPr/>
+        </p:nvSpPr>
+        <p:spPr>
+          <a:xfrm>
+            <a:off x="457200" y="2103120"/>
+            <a:ext cx="5577840" cy="457200"/>
+          </a:xfrm>
+          <a:prstGeom prst="rect">
+            <a:avLst/>
+          </a:prstGeom>
+          <a:solidFill>
+            <a:srgbClr val="1E3A5F"/>
+          </a:solidFill>
+          <a:ln>
+            <a:noFill/>
+          </a:ln>
+          <a:effectLst/>
+        </p:spPr>
+        <p:style>
+          <a:lnRef idx="1">
+            <a:schemeClr val="accent1"/>
+          </a:lnRef>
+          <a:fillRef idx="3">
+            <a:schemeClr val="accent1"/>
+          </a:fillRef>
+          <a:effectRef idx="2">
+            <a:schemeClr val="accent1"/>
+          </a:effectRef>
+          <a:fontRef idx="minor">
+            <a:schemeClr val="lt1"/>
+          </a:fontRef>
+        </p:style>
+        <p:txBody>
+          <a:bodyPr rtlCol="0" anchor="ctr"/>
+          <a:lstStyle/>
+          <a:p>
+            <a:pPr algn="ctr"/>
+          </a:p>
+        </p:txBody>
+      </p:sp>
+      <p:sp>
+        <p:nvSpPr>
+          <p:cNvPr id="16" name="TextBox 15"/>
+          <p:cNvSpPr txBox="1"/>
+          <p:nvPr/>
+        </p:nvSpPr>
+        <p:spPr>
+          <a:xfrm>
+            <a:off x="640080" y="2176272"/>
+            <a:ext cx="5303520" cy="320040"/>
+          </a:xfrm>
+          <a:prstGeom prst="rect">
+            <a:avLst/>
+          </a:prstGeom>
+          <a:noFill/>
+        </p:spPr>
+        <p:txBody>
+          <a:bodyPr wrap="square" lIns="45720" rIns="45720" tIns="18288" bIns="18288" anchor="t">
+            <a:spAutoFit/>
+          </a:bodyPr>
+          <a:lstStyle/>
+          <a:p>
+            <a:pPr algn="l"/>
+            <a:r>
+              <a:rPr sz="1200" b="1" i="0">
+                <a:solidFill>
+                  <a:srgbClr val="FFFFFF"/>
+                </a:solidFill>
+                <a:latin typeface="Calibri"/>
+              </a:rPr>
+              <a:t>1.  EmotionEarlyFusion  (scratch CNN)</a:t>
+            </a:r>
+          </a:p>
+        </p:txBody>
+      </p:sp>
+      <p:sp>
+        <p:nvSpPr>
+          <p:cNvPr id="17" name="TextBox 16"/>
+          <p:cNvSpPr txBox="1"/>
+          <p:nvPr/>
+        </p:nvSpPr>
+        <p:spPr>
+          <a:xfrm>
+            <a:off x="640080" y="2651760"/>
+            <a:ext cx="5212080" cy="320040"/>
+          </a:xfrm>
+          <a:prstGeom prst="rect">
+            <a:avLst/>
+          </a:prstGeom>
+          <a:noFill/>
+        </p:spPr>
+        <p:txBody>
+          <a:bodyPr wrap="square" lIns="45720" rIns="45720" tIns="18288" bIns="18288" anchor="t">
+            <a:spAutoFit/>
+          </a:bodyPr>
+          <a:lstStyle/>
+          <a:p>
+            <a:pPr algn="l"/>
+            <a:r>
+              <a:rPr sz="1000" b="0" i="1">
+                <a:solidFill>
+                  <a:srgbClr val="2E86AB"/>
+                </a:solidFill>
+                <a:latin typeface="Calibri"/>
+              </a:rPr>
+              <a:t>models.py : 275–323</a:t>
+            </a:r>
+          </a:p>
+        </p:txBody>
+      </p:sp>
+      <p:sp>
+        <p:nvSpPr>
+          <p:cNvPr id="18" name="TextBox 17"/>
+          <p:cNvSpPr txBox="1"/>
+          <p:nvPr/>
+        </p:nvSpPr>
+        <p:spPr>
+          <a:xfrm>
+            <a:off x="640080" y="2971800"/>
+            <a:ext cx="5212080" cy="1280160"/>
+          </a:xfrm>
+          <a:prstGeom prst="rect">
+            <a:avLst/>
+          </a:prstGeom>
+          <a:noFill/>
+        </p:spPr>
+        <p:txBody>
+          <a:bodyPr wrap="square" lIns="45720" rIns="45720" tIns="18288" bIns="18288">
+            <a:spAutoFit/>
+          </a:bodyPr>
+          <a:lstStyle/>
+          <a:p>
+            <a:pPr algn="l">
+              <a:spcAft>
+                <a:spcPts val="600"/>
+              </a:spcAft>
+            </a:pPr>
+            <a:r>
+              <a:rPr sz="1100" b="1">
+                <a:solidFill>
+                  <a:srgbClr val="1E3A5F"/>
+                </a:solidFill>
+                <a:latin typeface="Calibri"/>
+              </a:rPr>
+              <a:t>▸  </a:t>
+            </a:r>
+            <a:r>
+              <a:rPr sz="1100" b="0" i="0">
+                <a:solidFill>
+                  <a:srgbClr val="1E293B"/>
+                </a:solidFill>
+                <a:latin typeface="Calibri"/>
+              </a:rPr>
+              <a:t>Input: </a:t>
+            </a:r>
+            <a:r>
+              <a:rPr sz="1100" b="0" i="0">
+                <a:solidFill>
+                  <a:srgbClr val="1E293B"/>
+                </a:solidFill>
+                <a:latin typeface="Calibri"/>
+              </a:rPr>
+              <a:t>tensor 4-channel (R, G, B, landmark_heatmap) 224×224</a:t>
+            </a:r>
+          </a:p>
+          <a:p>
+            <a:pPr algn="l">
+              <a:spcAft>
+                <a:spcPts val="600"/>
+              </a:spcAft>
+            </a:pPr>
+            <a:r>
+              <a:rPr sz="1100" b="1">
+                <a:solidFill>
+                  <a:srgbClr val="1E3A5F"/>
+                </a:solidFill>
+                <a:latin typeface="Calibri"/>
+              </a:rPr>
+              <a:t>▸  </a:t>
+            </a:r>
+            <a:r>
+              <a:rPr sz="1100" b="0" i="0">
+                <a:solidFill>
+                  <a:srgbClr val="1E293B"/>
+                </a:solidFill>
+                <a:latin typeface="Calibri"/>
+              </a:rPr>
+              <a:t>First conv: </a:t>
+            </a:r>
+            <a:r>
+              <a:rPr sz="1100" b="0" i="0">
+                <a:solidFill>
+                  <a:srgbClr val="1E3A5F"/>
+                </a:solidFill>
+                <a:latin typeface="Consolas"/>
+              </a:rPr>
+              <a:t>nn.Conv2d(4, 32, 3, padding=1)</a:t>
+            </a:r>
+          </a:p>
+          <a:p>
+            <a:pPr algn="l">
+              <a:spcAft>
+                <a:spcPts val="600"/>
+              </a:spcAft>
+            </a:pPr>
+            <a:r>
+              <a:rPr sz="1100" b="1">
+                <a:solidFill>
+                  <a:srgbClr val="1E3A5F"/>
+                </a:solidFill>
+                <a:latin typeface="Calibri"/>
+              </a:rPr>
+              <a:t>▸  </a:t>
+            </a:r>
+            <a:r>
+              <a:rPr sz="1100" b="0" i="0">
+                <a:solidFill>
+                  <a:srgbClr val="1E293B"/>
+                </a:solidFill>
+                <a:latin typeface="Calibri"/>
+              </a:rPr>
+              <a:t>Mengikuti HAE-Net  </a:t>
+            </a:r>
+            <a:r>
+              <a:rPr sz="1100" b="0" i="1">
+                <a:solidFill>
+                  <a:srgbClr val="64748B"/>
+                </a:solidFill>
+                <a:latin typeface="Calibri"/>
+              </a:rPr>
+              <a:t>(Mo et al., MMM 2020)</a:t>
+            </a:r>
+          </a:p>
+          <a:p>
+            <a:pPr algn="l">
+              <a:spcAft>
+                <a:spcPts val="600"/>
+              </a:spcAft>
+            </a:pPr>
+            <a:r>
+              <a:rPr sz="1100" b="1">
+                <a:solidFill>
+                  <a:srgbClr val="1E3A5F"/>
+                </a:solidFill>
+                <a:latin typeface="Calibri"/>
+              </a:rPr>
+              <a:t>▸  </a:t>
+            </a:r>
             <a:r>
               <a:rPr sz="1100" b="1" i="0">
                 <a:solidFill>
+                  <a:srgbClr val="DC2626"/>
+                </a:solidFill>
+                <a:latin typeface="Calibri"/>
+              </a:rPr>
+              <a:t>Tidak ada gate / bobot fusi terpisah</a:t>
+            </a:r>
+          </a:p>
+        </p:txBody>
+      </p:sp>
+      <p:sp>
+        <p:nvSpPr>
+          <p:cNvPr id="19" name="Rectangle 18"/>
+          <p:cNvSpPr/>
+          <p:nvPr/>
+        </p:nvSpPr>
+        <p:spPr>
+          <a:xfrm>
+            <a:off x="6172200" y="2103120"/>
+            <a:ext cx="5577840" cy="2194560"/>
+          </a:xfrm>
+          <a:prstGeom prst="rect">
+            <a:avLst/>
+          </a:prstGeom>
+          <a:solidFill>
+            <a:srgbClr val="FFFFFF"/>
+          </a:solidFill>
+          <a:ln w="12700">
+            <a:solidFill>
+              <a:srgbClr val="E2E8F0"/>
+            </a:solidFill>
+          </a:ln>
+          <a:effectLst/>
+        </p:spPr>
+        <p:style>
+          <a:lnRef idx="1">
+            <a:schemeClr val="accent1"/>
+          </a:lnRef>
+          <a:fillRef idx="3">
+            <a:schemeClr val="accent1"/>
+          </a:fillRef>
+          <a:effectRef idx="2">
+            <a:schemeClr val="accent1"/>
+          </a:effectRef>
+          <a:fontRef idx="minor">
+            <a:schemeClr val="lt1"/>
+          </a:fontRef>
+        </p:style>
+        <p:txBody>
+          <a:bodyPr rtlCol="0" anchor="ctr"/>
+          <a:lstStyle/>
+          <a:p>
+            <a:pPr algn="ctr"/>
+          </a:p>
+        </p:txBody>
+      </p:sp>
+      <p:sp>
+        <p:nvSpPr>
+          <p:cNvPr id="20" name="Rectangle 19"/>
+          <p:cNvSpPr/>
+          <p:nvPr/>
+        </p:nvSpPr>
+        <p:spPr>
+          <a:xfrm>
+            <a:off x="6172200" y="2103120"/>
+            <a:ext cx="5577840" cy="457200"/>
+          </a:xfrm>
+          <a:prstGeom prst="rect">
+            <a:avLst/>
+          </a:prstGeom>
+          <a:solidFill>
+            <a:srgbClr val="2E86AB"/>
+          </a:solidFill>
+          <a:ln>
+            <a:noFill/>
+          </a:ln>
+          <a:effectLst/>
+        </p:spPr>
+        <p:style>
+          <a:lnRef idx="1">
+            <a:schemeClr val="accent1"/>
+          </a:lnRef>
+          <a:fillRef idx="3">
+            <a:schemeClr val="accent1"/>
+          </a:fillRef>
+          <a:effectRef idx="2">
+            <a:schemeClr val="accent1"/>
+          </a:effectRef>
+          <a:fontRef idx="minor">
+            <a:schemeClr val="lt1"/>
+          </a:fontRef>
+        </p:style>
+        <p:txBody>
+          <a:bodyPr rtlCol="0" anchor="ctr"/>
+          <a:lstStyle/>
+          <a:p>
+            <a:pPr algn="ctr"/>
+          </a:p>
+        </p:txBody>
+      </p:sp>
+      <p:sp>
+        <p:nvSpPr>
+          <p:cNvPr id="21" name="TextBox 20"/>
+          <p:cNvSpPr txBox="1"/>
+          <p:nvPr/>
+        </p:nvSpPr>
+        <p:spPr>
+          <a:xfrm>
+            <a:off x="6355080" y="2176272"/>
+            <a:ext cx="5303520" cy="320040"/>
+          </a:xfrm>
+          <a:prstGeom prst="rect">
+            <a:avLst/>
+          </a:prstGeom>
+          <a:noFill/>
+        </p:spPr>
+        <p:txBody>
+          <a:bodyPr wrap="square" lIns="45720" rIns="45720" tIns="18288" bIns="18288" anchor="t">
+            <a:spAutoFit/>
+          </a:bodyPr>
+          <a:lstStyle/>
+          <a:p>
+            <a:pPr algn="l"/>
+            <a:r>
+              <a:rPr sz="1200" b="1" i="0">
+                <a:solidFill>
+                  <a:srgbClr val="FFFFFF"/>
+                </a:solidFill>
+                <a:latin typeface="Calibri"/>
+              </a:rPr>
+              <a:t>2.  EmotionEarlyFusionTransfer  (ResNet18 TL)</a:t>
+            </a:r>
+          </a:p>
+        </p:txBody>
+      </p:sp>
+      <p:sp>
+        <p:nvSpPr>
+          <p:cNvPr id="22" name="TextBox 21"/>
+          <p:cNvSpPr txBox="1"/>
+          <p:nvPr/>
+        </p:nvSpPr>
+        <p:spPr>
+          <a:xfrm>
+            <a:off x="6355080" y="2651760"/>
+            <a:ext cx="5212080" cy="320040"/>
+          </a:xfrm>
+          <a:prstGeom prst="rect">
+            <a:avLst/>
+          </a:prstGeom>
+          <a:noFill/>
+        </p:spPr>
+        <p:txBody>
+          <a:bodyPr wrap="square" lIns="45720" rIns="45720" tIns="18288" bIns="18288" anchor="t">
+            <a:spAutoFit/>
+          </a:bodyPr>
+          <a:lstStyle/>
+          <a:p>
+            <a:pPr algn="l"/>
+            <a:r>
+              <a:rPr sz="1000" b="0" i="1">
+                <a:solidFill>
+                  <a:srgbClr val="2E86AB"/>
+                </a:solidFill>
+                <a:latin typeface="Calibri"/>
+              </a:rPr>
+              <a:t>models.py : 326–372</a:t>
+            </a:r>
+          </a:p>
+        </p:txBody>
+      </p:sp>
+      <p:sp>
+        <p:nvSpPr>
+          <p:cNvPr id="23" name="TextBox 22"/>
+          <p:cNvSpPr txBox="1"/>
+          <p:nvPr/>
+        </p:nvSpPr>
+        <p:spPr>
+          <a:xfrm>
+            <a:off x="6355080" y="2971800"/>
+            <a:ext cx="5212080" cy="1280160"/>
+          </a:xfrm>
+          <a:prstGeom prst="rect">
+            <a:avLst/>
+          </a:prstGeom>
+          <a:noFill/>
+        </p:spPr>
+        <p:txBody>
+          <a:bodyPr wrap="square" lIns="45720" rIns="45720" tIns="18288" bIns="18288">
+            <a:spAutoFit/>
+          </a:bodyPr>
+          <a:lstStyle/>
+          <a:p>
+            <a:pPr algn="l">
+              <a:spcAft>
+                <a:spcPts val="600"/>
+              </a:spcAft>
+            </a:pPr>
+            <a:r>
+              <a:rPr sz="1100" b="1">
+                <a:solidFill>
+                  <a:srgbClr val="2E86AB"/>
+                </a:solidFill>
+                <a:latin typeface="Calibri"/>
+              </a:rPr>
+              <a:t>▸  </a:t>
+            </a:r>
+            <a:r>
+              <a:rPr sz="1100" b="0" i="0">
+                <a:solidFill>
+                  <a:srgbClr val="1E293B"/>
+                </a:solidFill>
+                <a:latin typeface="Calibri"/>
+              </a:rPr>
+              <a:t>conv1 ResNet18 dimodifikasi </a:t>
+            </a:r>
+            <a:r>
+              <a:rPr sz="1100" b="0" i="0">
+                <a:solidFill>
                   <a:srgbClr val="1E3A5F"/>
                 </a:solidFill>
-                <a:latin typeface="Calibri"/>
-              </a:rPr>
-              <a:t>Terima kasih  ·  Diskusi dan masukan dipersilakan</a:t>
-            </a:r>
-          </a:p>
-        </p:txBody>
-      </p:sp>
+                <a:latin typeface="Consolas"/>
+              </a:rPr>
+              <a:t>in_channels = 3 → 4</a:t>
+            </a:r>
+          </a:p>
+          <a:p>
+            <a:pPr algn="l">
+              <a:spcAft>
+                <a:spcPts val="600"/>
+              </a:spcAft>
+            </a:pPr>
+            <a:r>
+              <a:rPr sz="1100" b="1">
+                <a:solidFill>
+                  <a:srgbClr val="2E86AB"/>
+                </a:solidFill>
+                <a:latin typeface="Calibri"/>
+              </a:rPr>
+              <a:t>▸  </a:t>
+            </a:r>
+            <a:r>
+              <a:rPr sz="1100" b="0" i="0">
+                <a:solidFill>
+                  <a:srgbClr val="1E293B"/>
+                </a:solidFill>
+                <a:latin typeface="Calibri"/>
+              </a:rPr>
+              <a:t>Channel ke-4 init = </a:t>
+            </a:r>
+            <a:r>
+              <a:rPr sz="1100" b="0" i="0">
+                <a:solidFill>
+                  <a:srgbClr val="1E3A5F"/>
+                </a:solidFill>
+                <a:latin typeface="Consolas"/>
+              </a:rPr>
+              <a:t>mean(RGB pretrained)</a:t>
+            </a:r>
+            <a:r>
+              <a:rPr sz="1000" b="0" i="0">
+                <a:solidFill>
+                  <a:srgbClr val="64748B"/>
+                </a:solidFill>
+                <a:latin typeface="Calibri"/>
+              </a:rPr>
+              <a:t>  (l. 351–356)</a:t>
+            </a:r>
+          </a:p>
+          <a:p>
+            <a:pPr algn="l">
+              <a:spcAft>
+                <a:spcPts val="600"/>
+              </a:spcAft>
+            </a:pPr>
+            <a:r>
+              <a:rPr sz="1100" b="1">
+                <a:solidFill>
+                  <a:srgbClr val="2E86AB"/>
+                </a:solidFill>
+                <a:latin typeface="Calibri"/>
+              </a:rPr>
+              <a:t>▸  </a:t>
+            </a:r>
+            <a:r>
+              <a:rPr sz="1100" b="0" i="0">
+                <a:solidFill>
+                  <a:srgbClr val="1E293B"/>
+                </a:solidFill>
+                <a:latin typeface="Calibri"/>
+              </a:rPr>
+              <a:t>Ini </a:t>
+            </a:r>
+            <a:r>
+              <a:rPr sz="1100" b="1" i="0">
+                <a:solidFill>
+                  <a:srgbClr val="1E293B"/>
+                </a:solidFill>
+                <a:latin typeface="Calibri"/>
+              </a:rPr>
+              <a:t>inisialisasi, bukan gating  </a:t>
+            </a:r>
+            <a:r>
+              <a:rPr sz="1100" b="0" i="0">
+                <a:solidFill>
+                  <a:srgbClr val="64748B"/>
+                </a:solidFill>
+                <a:latin typeface="Calibri"/>
+              </a:rPr>
+              <a:t>— bobot dilatih bebas</a:t>
+            </a:r>
+          </a:p>
+          <a:p>
+            <a:pPr algn="l">
+              <a:spcAft>
+                <a:spcPts val="600"/>
+              </a:spcAft>
+            </a:pPr>
+            <a:r>
+              <a:rPr sz="1100" b="1">
+                <a:solidFill>
+                  <a:srgbClr val="2E86AB"/>
+                </a:solidFill>
+                <a:latin typeface="Calibri"/>
+              </a:rPr>
+              <a:t>▸  </a:t>
+            </a:r>
+            <a:r>
+              <a:rPr sz="1100" b="1" i="0">
+                <a:solidFill>
+                  <a:srgbClr val="DC2626"/>
+                </a:solidFill>
+                <a:latin typeface="Calibri"/>
+              </a:rPr>
+              <a:t>Tidak ada sigmoid-gate / σ(·) yang membobot ulang stream</a:t>
+            </a:r>
+          </a:p>
+        </p:txBody>
+      </p:sp>
+      <p:sp>
+        <p:nvSpPr>
+          <p:cNvPr id="24" name="Rectangle 23"/>
+          <p:cNvSpPr/>
+          <p:nvPr/>
+        </p:nvSpPr>
+        <p:spPr>
+          <a:xfrm>
+            <a:off x="457200" y="4389120"/>
+            <a:ext cx="11247120" cy="548640"/>
+          </a:xfrm>
+          <a:prstGeom prst="rect">
+            <a:avLst/>
+          </a:prstGeom>
+          <a:solidFill>
+            <a:srgbClr val="F1F5F9"/>
+          </a:solidFill>
+          <a:ln>
+            <a:noFill/>
+          </a:ln>
+          <a:effectLst/>
+        </p:spPr>
+        <p:style>
+          <a:lnRef idx="1">
+            <a:schemeClr val="accent1"/>
+          </a:lnRef>
+          <a:fillRef idx="3">
+            <a:schemeClr val="accent1"/>
+          </a:fillRef>
+          <a:effectRef idx="2">
+            <a:schemeClr val="accent1"/>
+          </a:effectRef>
+          <a:fontRef idx="minor">
+            <a:schemeClr val="lt1"/>
+          </a:fontRef>
+        </p:style>
+        <p:txBody>
+          <a:bodyPr rtlCol="0" anchor="ctr"/>
+          <a:lstStyle/>
+          <a:p>
+            <a:pPr algn="ctr"/>
+          </a:p>
+        </p:txBody>
+      </p:sp>
+      <p:sp>
+        <p:nvSpPr>
+          <p:cNvPr id="25" name="TextBox 24"/>
+          <p:cNvSpPr txBox="1"/>
+          <p:nvPr/>
+        </p:nvSpPr>
+        <p:spPr>
+          <a:xfrm>
+            <a:off x="640080" y="4480560"/>
+            <a:ext cx="10972800" cy="365760"/>
+          </a:xfrm>
+          <a:prstGeom prst="rect">
+            <a:avLst/>
+          </a:prstGeom>
+          <a:noFill/>
+        </p:spPr>
+        <p:txBody>
+          <a:bodyPr wrap="square" lIns="45720" rIns="45720" tIns="18288" bIns="18288" anchor="t">
+            <a:spAutoFit/>
+          </a:bodyPr>
+          <a:lstStyle/>
+          <a:p>
+            <a:pPr algn="l"/>
+            <a:r>
+              <a:rPr sz="1200" b="1" i="0">
+                <a:solidFill>
+                  <a:srgbClr val="E63946"/>
+                </a:solidFill>
+                <a:latin typeface="Calibri"/>
+              </a:rPr>
+              <a:t>3.  </a:t>
+            </a:r>
+            <a:r>
+              <a:rPr sz="1200" b="1" i="0">
+                <a:solidFill>
+                  <a:srgbClr val="1E293B"/>
+                </a:solidFill>
+                <a:latin typeface="Calibri"/>
+              </a:rPr>
+              <a:t>Grep models.py: </a:t>
+            </a:r>
+            <a:r>
+              <a:rPr sz="1200" b="0" i="0">
+                <a:solidFill>
+                  <a:srgbClr val="1E293B"/>
+                </a:solidFill>
+                <a:latin typeface="Calibri"/>
+              </a:rPr>
+              <a:t>tidak ditemukan keyword  </a:t>
+            </a:r>
+            <a:r>
+              <a:rPr sz="1100" b="0" i="0">
+                <a:solidFill>
+                  <a:srgbClr val="1E3A5F"/>
+                </a:solidFill>
+                <a:latin typeface="Consolas"/>
+              </a:rPr>
+              <a:t>gate / gating / sigmoid+fusion / α·β learnable  </a:t>
+            </a:r>
+            <a:r>
+              <a:rPr sz="1100" b="0" i="0">
+                <a:solidFill>
+                  <a:srgbClr val="1E293B"/>
+                </a:solidFill>
+                <a:latin typeface="Calibri"/>
+              </a:rPr>
+              <a:t>·  torch.cat hanya muncul di Intermediate Fusion (l. 436, 598, 648)</a:t>
+            </a:r>
+          </a:p>
+        </p:txBody>
+      </p:sp>
+      <p:sp>
+        <p:nvSpPr>
+          <p:cNvPr id="26" name="TextBox 25"/>
+          <p:cNvSpPr txBox="1"/>
+          <p:nvPr/>
+        </p:nvSpPr>
+        <p:spPr>
+          <a:xfrm>
+            <a:off x="457200" y="5029200"/>
+            <a:ext cx="11247120" cy="320040"/>
+          </a:xfrm>
+          <a:prstGeom prst="rect">
+            <a:avLst/>
+          </a:prstGeom>
+          <a:noFill/>
+        </p:spPr>
+        <p:txBody>
+          <a:bodyPr wrap="square" lIns="45720" rIns="45720" tIns="18288" bIns="18288" anchor="t">
+            <a:spAutoFit/>
+          </a:bodyPr>
+          <a:lstStyle/>
+          <a:p>
+            <a:pPr algn="l"/>
+            <a:r>
+              <a:rPr sz="1300" b="1" i="0">
+                <a:solidFill>
+                  <a:srgbClr val="1E3A5F"/>
+                </a:solidFill>
+                <a:latin typeface="Calibri"/>
+              </a:rPr>
+              <a:t>Ringkasan tipe fusi di project ini</a:t>
+            </a:r>
+          </a:p>
+        </p:txBody>
+      </p:sp>
+      <p:graphicFrame>
+        <p:nvGraphicFramePr>
+          <p:cNvPr id="27" name="Table 26"/>
+          <p:cNvGraphicFramePr>
+            <a:graphicFrameLocks noGrp="1"/>
+          </p:cNvGraphicFramePr>
+          <p:nvPr/>
+        </p:nvGraphicFramePr>
+        <p:xfrm>
+          <a:off x="457200" y="5394960"/>
+          <a:ext cx="11247120" cy="960120"/>
+        </p:xfrm>
+        <a:graphic>
+          <a:graphicData uri="http://schemas.openxmlformats.org/drawingml/2006/table">
+            <a:tbl>
+              <a:tblPr firstRow="1" bandRow="1">
+                <a:tableStyleId>{5C22544A-7EE6-4342-B048-85BDC9FD1C3A}</a:tableStyleId>
+              </a:tblPr>
+              <a:tblGrid>
+                <a:gridCol w="2377440"/>
+                <a:gridCol w="1554480"/>
+                <a:gridCol w="4389120"/>
+                <a:gridCol w="2926080"/>
+              </a:tblGrid>
+              <a:tr h="240030">
+                <a:tc>
+                  <a:txBody>
+                    <a:bodyPr/>
+                    <a:lstStyle/>
+                    <a:p>
+                      <a:pPr algn="l"/>
+                      <a:r>
+                        <a:rPr sz="1100" b="1">
+                          <a:solidFill>
+                            <a:srgbClr val="FFFFFF"/>
+                          </a:solidFill>
+                          <a:latin typeface="Calibri"/>
+                        </a:rPr>
+                        <a:t>Skema</a:t>
+                      </a:r>
+                    </a:p>
+                  </a:txBody>
+                  <a:tcPr marL="36576" marR="36576" marT="18288" marB="18288">
+                    <a:solidFill>
+                      <a:srgbClr val="1E3A5F"/>
+                    </a:solidFill>
+                  </a:tcPr>
+                </a:tc>
+                <a:tc>
+                  <a:txBody>
+                    <a:bodyPr/>
+                    <a:lstStyle/>
+                    <a:p>
+                      <a:pPr algn="ctr"/>
+                      <a:r>
+                        <a:rPr sz="1100" b="1">
+                          <a:solidFill>
+                            <a:srgbClr val="FFFFFF"/>
+                          </a:solidFill>
+                          <a:latin typeface="Calibri"/>
+                        </a:rPr>
+                        <a:t>Stage</a:t>
+                      </a:r>
+                    </a:p>
+                  </a:txBody>
+                  <a:tcPr marL="36576" marR="36576" marT="18288" marB="18288">
+                    <a:solidFill>
+                      <a:srgbClr val="1E3A5F"/>
+                    </a:solidFill>
+                  </a:tcPr>
+                </a:tc>
+                <a:tc>
+                  <a:txBody>
+                    <a:bodyPr/>
+                    <a:lstStyle/>
+                    <a:p>
+                      <a:pPr algn="ctr"/>
+                      <a:r>
+                        <a:rPr sz="1100" b="1">
+                          <a:solidFill>
+                            <a:srgbClr val="FFFFFF"/>
+                          </a:solidFill>
+                          <a:latin typeface="Calibri"/>
+                        </a:rPr>
+                        <a:t>Mekanisme</a:t>
+                      </a:r>
+                    </a:p>
+                  </a:txBody>
+                  <a:tcPr marL="36576" marR="36576" marT="18288" marB="18288">
+                    <a:solidFill>
+                      <a:srgbClr val="1E3A5F"/>
+                    </a:solidFill>
+                  </a:tcPr>
+                </a:tc>
+                <a:tc>
+                  <a:txBody>
+                    <a:bodyPr/>
+                    <a:lstStyle/>
+                    <a:p>
+                      <a:pPr algn="ctr"/>
+                      <a:r>
+                        <a:rPr sz="1100" b="1">
+                          <a:solidFill>
+                            <a:srgbClr val="FFFFFF"/>
+                          </a:solidFill>
+                          <a:latin typeface="Calibri"/>
+                        </a:rPr>
+                        <a:t>Kode</a:t>
+                      </a:r>
+                    </a:p>
+                  </a:txBody>
+                  <a:tcPr marL="36576" marR="36576" marT="18288" marB="18288">
+                    <a:solidFill>
+                      <a:srgbClr val="1E3A5F"/>
+                    </a:solidFill>
+                  </a:tcPr>
+                </a:tc>
+              </a:tr>
+              <a:tr h="240030">
+                <a:tc>
+                  <a:txBody>
+                    <a:bodyPr/>
+                    <a:lstStyle/>
+                    <a:p>
+                      <a:pPr algn="l"/>
+                      <a:r>
+                        <a:rPr sz="1100" b="1">
+                          <a:solidFill>
+                            <a:srgbClr val="1E293B"/>
+                          </a:solidFill>
+                          <a:latin typeface="Calibri"/>
+                        </a:rPr>
+                        <a:t>Early Fusion</a:t>
+                      </a:r>
+                    </a:p>
+                  </a:txBody>
+                  <a:tcPr marL="36576" marR="36576" marT="18288" marB="18288">
+                    <a:solidFill>
+                      <a:srgbClr val="FFFFFF"/>
+                    </a:solidFill>
+                  </a:tcPr>
+                </a:tc>
+                <a:tc>
+                  <a:txBody>
+                    <a:bodyPr/>
+                    <a:lstStyle/>
+                    <a:p>
+                      <a:pPr algn="ctr"/>
+                      <a:r>
+                        <a:rPr sz="1100" b="0">
+                          <a:solidFill>
+                            <a:srgbClr val="1E293B"/>
+                          </a:solidFill>
+                          <a:latin typeface="Calibri"/>
+                        </a:rPr>
+                        <a:t>Input-level</a:t>
+                      </a:r>
+                    </a:p>
+                  </a:txBody>
+                  <a:tcPr marL="36576" marR="36576" marT="18288" marB="18288">
+                    <a:solidFill>
+                      <a:srgbClr val="FFFFFF"/>
+                    </a:solidFill>
+                  </a:tcPr>
+                </a:tc>
+                <a:tc>
+                  <a:txBody>
+                    <a:bodyPr/>
+                    <a:lstStyle/>
+                    <a:p>
+                      <a:pPr algn="ctr"/>
+                      <a:r>
+                        <a:rPr sz="1100" b="1">
+                          <a:solidFill>
+                            <a:srgbClr val="E63946"/>
+                          </a:solidFill>
+                          <a:latin typeface="Calibri"/>
+                        </a:rPr>
+                        <a:t>Channel concat (RGB + heatmap → 4-ch)</a:t>
+                      </a:r>
+                    </a:p>
+                  </a:txBody>
+                  <a:tcPr marL="36576" marR="36576" marT="18288" marB="18288">
+                    <a:solidFill>
+                      <a:srgbClr val="FFFFFF"/>
+                    </a:solidFill>
+                  </a:tcPr>
+                </a:tc>
+                <a:tc>
+                  <a:txBody>
+                    <a:bodyPr/>
+                    <a:lstStyle/>
+                    <a:p>
+                      <a:pPr algn="ctr"/>
+                      <a:r>
+                        <a:rPr sz="1100" b="0">
+                          <a:solidFill>
+                            <a:srgbClr val="1E293B"/>
+                          </a:solidFill>
+                          <a:latin typeface="Calibri"/>
+                        </a:rPr>
+                        <a:t>EmotionEarlyFusion(Transfer)</a:t>
+                      </a:r>
+                    </a:p>
+                  </a:txBody>
+                  <a:tcPr marL="36576" marR="36576" marT="18288" marB="18288">
+                    <a:solidFill>
+                      <a:srgbClr val="FFFFFF"/>
+                    </a:solidFill>
+                  </a:tcPr>
+                </a:tc>
+              </a:tr>
+              <a:tr h="240030">
+                <a:tc>
+                  <a:txBody>
+                    <a:bodyPr/>
+                    <a:lstStyle/>
+                    <a:p>
+                      <a:pPr algn="l"/>
+                      <a:r>
+                        <a:rPr sz="1100" b="1">
+                          <a:solidFill>
+                            <a:srgbClr val="1E293B"/>
+                          </a:solidFill>
+                          <a:latin typeface="Calibri"/>
+                        </a:rPr>
+                        <a:t>Intermediate Fusion</a:t>
+                      </a:r>
+                    </a:p>
+                  </a:txBody>
+                  <a:tcPr marL="36576" marR="36576" marT="18288" marB="18288">
+                    <a:solidFill>
+                      <a:srgbClr val="F1F5F9"/>
+                    </a:solidFill>
+                  </a:tcPr>
+                </a:tc>
+                <a:tc>
+                  <a:txBody>
+                    <a:bodyPr/>
+                    <a:lstStyle/>
+                    <a:p>
+                      <a:pPr algn="ctr"/>
+                      <a:r>
+                        <a:rPr sz="1100" b="0">
+                          <a:solidFill>
+                            <a:srgbClr val="1E293B"/>
+                          </a:solidFill>
+                          <a:latin typeface="Calibri"/>
+                        </a:rPr>
+                        <a:t>Feature-level</a:t>
+                      </a:r>
+                    </a:p>
+                  </a:txBody>
+                  <a:tcPr marL="36576" marR="36576" marT="18288" marB="18288">
+                    <a:solidFill>
+                      <a:srgbClr val="F1F5F9"/>
+                    </a:solidFill>
+                  </a:tcPr>
+                </a:tc>
+                <a:tc>
+                  <a:txBody>
+                    <a:bodyPr/>
+                    <a:lstStyle/>
+                    <a:p>
+                      <a:pPr algn="ctr"/>
+                      <a:r>
+                        <a:rPr sz="1100" b="0">
+                          <a:solidFill>
+                            <a:srgbClr val="1E293B"/>
+                          </a:solidFill>
+                          <a:latin typeface="Calibri"/>
+                        </a:rPr>
+                        <a:t>torch.cat([img_feat, lm_feat], dim=1)</a:t>
+                      </a:r>
+                    </a:p>
+                  </a:txBody>
+                  <a:tcPr marL="36576" marR="36576" marT="18288" marB="18288">
+                    <a:solidFill>
+                      <a:srgbClr val="F1F5F9"/>
+                    </a:solidFill>
+                  </a:tcPr>
+                </a:tc>
+                <a:tc>
+                  <a:txBody>
+                    <a:bodyPr/>
+                    <a:lstStyle/>
+                    <a:p>
+                      <a:pPr algn="ctr"/>
+                      <a:r>
+                        <a:rPr sz="1100" b="0">
+                          <a:solidFill>
+                            <a:srgbClr val="1E293B"/>
+                          </a:solidFill>
+                          <a:latin typeface="Calibri"/>
+                        </a:rPr>
+                        <a:t>IntermediateFusion*</a:t>
+                      </a:r>
+                    </a:p>
+                  </a:txBody>
+                  <a:tcPr marL="36576" marR="36576" marT="18288" marB="18288">
+                    <a:solidFill>
+                      <a:srgbClr val="F1F5F9"/>
+                    </a:solidFill>
+                  </a:tcPr>
+                </a:tc>
+              </a:tr>
+              <a:tr h="240030">
+                <a:tc>
+                  <a:txBody>
+                    <a:bodyPr/>
+                    <a:lstStyle/>
+                    <a:p>
+                      <a:pPr algn="l"/>
+                      <a:r>
+                        <a:rPr sz="1100" b="1">
+                          <a:solidFill>
+                            <a:srgbClr val="1E293B"/>
+                          </a:solidFill>
+                          <a:latin typeface="Calibri"/>
+                        </a:rPr>
+                        <a:t>Late Fusion</a:t>
+                      </a:r>
+                    </a:p>
+                  </a:txBody>
+                  <a:tcPr marL="36576" marR="36576" marT="18288" marB="18288">
+                    <a:solidFill>
+                      <a:srgbClr val="FFFFFF"/>
+                    </a:solidFill>
+                  </a:tcPr>
+                </a:tc>
+                <a:tc>
+                  <a:txBody>
+                    <a:bodyPr/>
+                    <a:lstStyle/>
+                    <a:p>
+                      <a:pPr algn="ctr"/>
+                      <a:r>
+                        <a:rPr sz="1100" b="0">
+                          <a:solidFill>
+                            <a:srgbClr val="1E293B"/>
+                          </a:solidFill>
+                          <a:latin typeface="Calibri"/>
+                        </a:rPr>
+                        <a:t>Decision-level</a:t>
+                      </a:r>
+                    </a:p>
+                  </a:txBody>
+                  <a:tcPr marL="36576" marR="36576" marT="18288" marB="18288">
+                    <a:solidFill>
+                      <a:srgbClr val="FFFFFF"/>
+                    </a:solidFill>
+                  </a:tcPr>
+                </a:tc>
+                <a:tc>
+                  <a:txBody>
+                    <a:bodyPr/>
+                    <a:lstStyle/>
+                    <a:p>
+                      <a:pPr algn="ctr"/>
+                      <a:r>
+                        <a:rPr sz="1100" b="0">
+                          <a:solidFill>
+                            <a:srgbClr val="1E293B"/>
+                          </a:solidFill>
+                          <a:latin typeface="Calibri"/>
+                        </a:rPr>
+                        <a:t>Gabung di level logit / prediksi</a:t>
+                      </a:r>
+                    </a:p>
+                  </a:txBody>
+                  <a:tcPr marL="36576" marR="36576" marT="18288" marB="18288">
+                    <a:solidFill>
+                      <a:srgbClr val="FFFFFF"/>
+                    </a:solidFill>
+                  </a:tcPr>
+                </a:tc>
+                <a:tc>
+                  <a:txBody>
+                    <a:bodyPr/>
+                    <a:lstStyle/>
+                    <a:p>
+                      <a:pPr algn="ctr"/>
+                      <a:r>
+                        <a:rPr sz="1100" b="0">
+                          <a:solidFill>
+                            <a:srgbClr val="1E293B"/>
+                          </a:solidFill>
+                          <a:latin typeface="Calibri"/>
+                        </a:rPr>
+                        <a:t>folder late_fusion*</a:t>
+                      </a:r>
+                    </a:p>
+                  </a:txBody>
+                  <a:tcPr marL="36576" marR="36576" marT="18288" marB="18288">
+                    <a:solidFill>
+                      <a:srgbClr val="FFFFFF"/>
+                    </a:solidFill>
+                  </a:tcPr>
+                </a:tc>
+              </a:tr>
+            </a:tbl>
+          </a:graphicData>
+        </a:graphic>
+      </p:graphicFrame>
     </p:spTree>
   </p:cSld>
   <p:clrMapOvr>
@@ -13420,7 +15017,7 @@
                 </a:solidFill>
                 <a:latin typeface="Calibri"/>
               </a:rPr>
-              <a:t>2 / 16</a:t>
+              <a:t>2 / 17</a:t>
             </a:r>
           </a:p>
         </p:txBody>
@@ -13949,7 +15546,7 @@
                 </a:solidFill>
                 <a:latin typeface="Calibri"/>
               </a:rPr>
-              <a:t>3 / 16</a:t>
+              <a:t>3 / 17</a:t>
             </a:r>
           </a:p>
         </p:txBody>
@@ -15158,7 +16755,7 @@
                 </a:solidFill>
                 <a:latin typeface="Calibri"/>
               </a:rPr>
-              <a:t>4 / 16</a:t>
+              <a:t>4 / 17</a:t>
             </a:r>
           </a:p>
         </p:txBody>
@@ -17296,7 +18893,7 @@
                 </a:solidFill>
                 <a:latin typeface="Calibri"/>
               </a:rPr>
-              <a:t>5 / 16</a:t>
+              <a:t>5 / 17</a:t>
             </a:r>
           </a:p>
         </p:txBody>
@@ -18389,7 +19986,7 @@
                 </a:solidFill>
                 <a:latin typeface="Calibri"/>
               </a:rPr>
-              <a:t>6 / 16</a:t>
+              <a:t>6 / 17</a:t>
             </a:r>
           </a:p>
         </p:txBody>
@@ -20055,7 +21652,7 @@
                 </a:solidFill>
                 <a:latin typeface="Calibri"/>
               </a:rPr>
-              <a:t>7 / 16</a:t>
+              <a:t>7 / 17</a:t>
             </a:r>
           </a:p>
         </p:txBody>
@@ -21739,7 +23336,7 @@
                 </a:solidFill>
                 <a:latin typeface="Calibri"/>
               </a:rPr>
-              <a:t>8 / 16</a:t>
+              <a:t>8 / 17</a:t>
             </a:r>
           </a:p>
         </p:txBody>
@@ -24002,7 +25599,7 @@
                 </a:solidFill>
                 <a:latin typeface="Calibri"/>
               </a:rPr>
-              <a:t>9 / 16</a:t>
+              <a:t>9 / 17</a:t>
             </a:r>
           </a:p>
         </p:txBody>

</xml_diff>